<commit_message>
separate into agu and clarify lsu behaviour
</commit_message>
<xml_diff>
--- a/docs/final presentation.pptx
+++ b/docs/final presentation.pptx
@@ -267,7 +267,7 @@
           <a:p>
             <a:fld id="{C8C63B6A-6BCC-454B-8859-8F44071057AF}" type="datetimeFigureOut">
               <a:rPr lang="en-GB" smtClean="0"/>
-              <a:t>19/04/2026</a:t>
+              <a:t>28/04/2026</a:t>
             </a:fld>
             <a:endParaRPr lang="en-GB"/>
           </a:p>
@@ -467,7 +467,7 @@
           <a:p>
             <a:fld id="{C8C63B6A-6BCC-454B-8859-8F44071057AF}" type="datetimeFigureOut">
               <a:rPr lang="en-GB" smtClean="0"/>
-              <a:t>19/04/2026</a:t>
+              <a:t>28/04/2026</a:t>
             </a:fld>
             <a:endParaRPr lang="en-GB"/>
           </a:p>
@@ -677,7 +677,7 @@
           <a:p>
             <a:fld id="{C8C63B6A-6BCC-454B-8859-8F44071057AF}" type="datetimeFigureOut">
               <a:rPr lang="en-GB" smtClean="0"/>
-              <a:t>19/04/2026</a:t>
+              <a:t>28/04/2026</a:t>
             </a:fld>
             <a:endParaRPr lang="en-GB"/>
           </a:p>
@@ -877,7 +877,7 @@
           <a:p>
             <a:fld id="{C8C63B6A-6BCC-454B-8859-8F44071057AF}" type="datetimeFigureOut">
               <a:rPr lang="en-GB" smtClean="0"/>
-              <a:t>19/04/2026</a:t>
+              <a:t>28/04/2026</a:t>
             </a:fld>
             <a:endParaRPr lang="en-GB"/>
           </a:p>
@@ -1153,7 +1153,7 @@
           <a:p>
             <a:fld id="{C8C63B6A-6BCC-454B-8859-8F44071057AF}" type="datetimeFigureOut">
               <a:rPr lang="en-GB" smtClean="0"/>
-              <a:t>19/04/2026</a:t>
+              <a:t>28/04/2026</a:t>
             </a:fld>
             <a:endParaRPr lang="en-GB"/>
           </a:p>
@@ -1421,7 +1421,7 @@
           <a:p>
             <a:fld id="{C8C63B6A-6BCC-454B-8859-8F44071057AF}" type="datetimeFigureOut">
               <a:rPr lang="en-GB" smtClean="0"/>
-              <a:t>19/04/2026</a:t>
+              <a:t>28/04/2026</a:t>
             </a:fld>
             <a:endParaRPr lang="en-GB"/>
           </a:p>
@@ -1836,7 +1836,7 @@
           <a:p>
             <a:fld id="{C8C63B6A-6BCC-454B-8859-8F44071057AF}" type="datetimeFigureOut">
               <a:rPr lang="en-GB" smtClean="0"/>
-              <a:t>19/04/2026</a:t>
+              <a:t>28/04/2026</a:t>
             </a:fld>
             <a:endParaRPr lang="en-GB"/>
           </a:p>
@@ -1978,7 +1978,7 @@
           <a:p>
             <a:fld id="{C8C63B6A-6BCC-454B-8859-8F44071057AF}" type="datetimeFigureOut">
               <a:rPr lang="en-GB" smtClean="0"/>
-              <a:t>19/04/2026</a:t>
+              <a:t>28/04/2026</a:t>
             </a:fld>
             <a:endParaRPr lang="en-GB"/>
           </a:p>
@@ -2091,7 +2091,7 @@
           <a:p>
             <a:fld id="{C8C63B6A-6BCC-454B-8859-8F44071057AF}" type="datetimeFigureOut">
               <a:rPr lang="en-GB" smtClean="0"/>
-              <a:t>19/04/2026</a:t>
+              <a:t>28/04/2026</a:t>
             </a:fld>
             <a:endParaRPr lang="en-GB"/>
           </a:p>
@@ -2404,7 +2404,7 @@
           <a:p>
             <a:fld id="{C8C63B6A-6BCC-454B-8859-8F44071057AF}" type="datetimeFigureOut">
               <a:rPr lang="en-GB" smtClean="0"/>
-              <a:t>19/04/2026</a:t>
+              <a:t>28/04/2026</a:t>
             </a:fld>
             <a:endParaRPr lang="en-GB"/>
           </a:p>
@@ -2693,7 +2693,7 @@
           <a:p>
             <a:fld id="{C8C63B6A-6BCC-454B-8859-8F44071057AF}" type="datetimeFigureOut">
               <a:rPr lang="en-GB" smtClean="0"/>
-              <a:t>19/04/2026</a:t>
+              <a:t>28/04/2026</a:t>
             </a:fld>
             <a:endParaRPr lang="en-GB"/>
           </a:p>
@@ -2936,7 +2936,7 @@
           <a:p>
             <a:fld id="{C8C63B6A-6BCC-454B-8859-8F44071057AF}" type="datetimeFigureOut">
               <a:rPr lang="en-GB" smtClean="0"/>
-              <a:t>19/04/2026</a:t>
+              <a:t>28/04/2026</a:t>
             </a:fld>
             <a:endParaRPr lang="en-GB"/>
           </a:p>
@@ -3549,14 +3549,215 @@
         <p:spPr>
           <a:xfrm>
             <a:off x="742950" y="559952"/>
-            <a:ext cx="5353050" cy="5860750"/>
+            <a:ext cx="6007654" cy="5860750"/>
           </a:xfrm>
         </p:spPr>
         <p:txBody>
           <a:bodyPr>
-            <a:normAutofit/>
+            <a:normAutofit fontScale="92500" lnSpcReduction="10000"/>
           </a:bodyPr>
           <a:lstStyle/>
+          <a:p>
+            <a:pPr marL="0" indent="0">
+              <a:buNone/>
+              <a:defRPr/>
+            </a:pPr>
+            <a:r>
+              <a:rPr lang="en-GB" sz="1600" dirty="0">
+                <a:solidFill>
+                  <a:prstClr val="black"/>
+                </a:solidFill>
+                <a:latin typeface="JetBrains Mono" panose="02000009000000000000" pitchFamily="49" charset="0"/>
+                <a:ea typeface="JetBrains Mono" panose="02000009000000000000" pitchFamily="49" charset="0"/>
+                <a:cs typeface="JetBrains Mono" panose="02000009000000000000" pitchFamily="49" charset="0"/>
+              </a:rPr>
+              <a:t>RV32I base integer instructions (majority)</a:t>
+            </a:r>
+          </a:p>
+          <a:p>
+            <a:pPr marL="457200" lvl="1" indent="0">
+              <a:buNone/>
+              <a:defRPr/>
+            </a:pPr>
+            <a:r>
+              <a:rPr lang="en-GB" sz="1100" dirty="0">
+                <a:solidFill>
+                  <a:prstClr val="black"/>
+                </a:solidFill>
+                <a:latin typeface="JetBrains Mono" panose="02000009000000000000" pitchFamily="49" charset="0"/>
+                <a:ea typeface="JetBrains Mono" panose="02000009000000000000" pitchFamily="49" charset="0"/>
+                <a:cs typeface="JetBrains Mono" panose="02000009000000000000" pitchFamily="49" charset="0"/>
+              </a:rPr>
+              <a:t>no </a:t>
+            </a:r>
+            <a:r>
+              <a:rPr lang="en-GB" sz="1100" dirty="0" err="1">
+                <a:solidFill>
+                  <a:prstClr val="black"/>
+                </a:solidFill>
+                <a:latin typeface="JetBrains Mono" panose="02000009000000000000" pitchFamily="49" charset="0"/>
+                <a:ea typeface="JetBrains Mono" panose="02000009000000000000" pitchFamily="49" charset="0"/>
+                <a:cs typeface="JetBrains Mono" panose="02000009000000000000" pitchFamily="49" charset="0"/>
+              </a:rPr>
+              <a:t>ebreak</a:t>
+            </a:r>
+            <a:r>
+              <a:rPr lang="en-GB" sz="1100" dirty="0">
+                <a:solidFill>
+                  <a:prstClr val="black"/>
+                </a:solidFill>
+                <a:latin typeface="JetBrains Mono" panose="02000009000000000000" pitchFamily="49" charset="0"/>
+                <a:ea typeface="JetBrains Mono" panose="02000009000000000000" pitchFamily="49" charset="0"/>
+                <a:cs typeface="JetBrains Mono" panose="02000009000000000000" pitchFamily="49" charset="0"/>
+              </a:rPr>
+              <a:t>/</a:t>
+            </a:r>
+            <a:r>
+              <a:rPr lang="en-GB" sz="1100" dirty="0" err="1">
+                <a:solidFill>
+                  <a:prstClr val="black"/>
+                </a:solidFill>
+                <a:latin typeface="JetBrains Mono" panose="02000009000000000000" pitchFamily="49" charset="0"/>
+                <a:ea typeface="JetBrains Mono" panose="02000009000000000000" pitchFamily="49" charset="0"/>
+                <a:cs typeface="JetBrains Mono" panose="02000009000000000000" pitchFamily="49" charset="0"/>
+              </a:rPr>
+              <a:t>ecall</a:t>
+            </a:r>
+            <a:r>
+              <a:rPr lang="en-GB" sz="1100" dirty="0">
+                <a:solidFill>
+                  <a:prstClr val="black"/>
+                </a:solidFill>
+                <a:latin typeface="JetBrains Mono" panose="02000009000000000000" pitchFamily="49" charset="0"/>
+                <a:ea typeface="JetBrains Mono" panose="02000009000000000000" pitchFamily="49" charset="0"/>
+                <a:cs typeface="JetBrains Mono" panose="02000009000000000000" pitchFamily="49" charset="0"/>
+              </a:rPr>
+              <a:t>/fence/</a:t>
+            </a:r>
+            <a:r>
+              <a:rPr lang="en-GB" sz="1100" dirty="0" err="1">
+                <a:solidFill>
+                  <a:prstClr val="black"/>
+                </a:solidFill>
+                <a:latin typeface="JetBrains Mono" panose="02000009000000000000" pitchFamily="49" charset="0"/>
+                <a:ea typeface="JetBrains Mono" panose="02000009000000000000" pitchFamily="49" charset="0"/>
+                <a:cs typeface="JetBrains Mono" panose="02000009000000000000" pitchFamily="49" charset="0"/>
+              </a:rPr>
+              <a:t>csr</a:t>
+            </a:r>
+            <a:endParaRPr lang="en-GB" sz="1100" dirty="0">
+              <a:solidFill>
+                <a:prstClr val="black"/>
+              </a:solidFill>
+              <a:latin typeface="JetBrains Mono" panose="02000009000000000000" pitchFamily="49" charset="0"/>
+              <a:ea typeface="JetBrains Mono" panose="02000009000000000000" pitchFamily="49" charset="0"/>
+              <a:cs typeface="JetBrains Mono" panose="02000009000000000000" pitchFamily="49" charset="0"/>
+            </a:endParaRPr>
+          </a:p>
+          <a:p>
+            <a:pPr marL="0" lvl="0" indent="0">
+              <a:buNone/>
+              <a:defRPr/>
+            </a:pPr>
+            <a:r>
+              <a:rPr lang="en-GB" sz="1600" dirty="0">
+                <a:solidFill>
+                  <a:prstClr val="black"/>
+                </a:solidFill>
+                <a:latin typeface="JetBrains Mono" panose="02000009000000000000" pitchFamily="49" charset="0"/>
+                <a:ea typeface="JetBrains Mono" panose="02000009000000000000" pitchFamily="49" charset="0"/>
+                <a:cs typeface="JetBrains Mono" panose="02000009000000000000" pitchFamily="49" charset="0"/>
+              </a:rPr>
+              <a:t>RV32M multiply/divide extension (full)</a:t>
+            </a:r>
+          </a:p>
+          <a:p>
+            <a:pPr marL="0" indent="0">
+              <a:buNone/>
+              <a:defRPr/>
+            </a:pPr>
+            <a:r>
+              <a:rPr lang="en-GB" sz="1600" dirty="0">
+                <a:solidFill>
+                  <a:prstClr val="black"/>
+                </a:solidFill>
+                <a:latin typeface="JetBrains Mono" panose="02000009000000000000" pitchFamily="49" charset="0"/>
+                <a:ea typeface="JetBrains Mono" panose="02000009000000000000" pitchFamily="49" charset="0"/>
+                <a:cs typeface="JetBrains Mono" panose="02000009000000000000" pitchFamily="49" charset="0"/>
+              </a:rPr>
+              <a:t>RV32F floating-point extension (majority)</a:t>
+            </a:r>
+          </a:p>
+          <a:p>
+            <a:pPr marL="457200" lvl="1" indent="0">
+              <a:buNone/>
+              <a:defRPr/>
+            </a:pPr>
+            <a:r>
+              <a:rPr lang="en-GB" sz="1100" dirty="0">
+                <a:solidFill>
+                  <a:prstClr val="black"/>
+                </a:solidFill>
+                <a:latin typeface="JetBrains Mono" panose="02000009000000000000" pitchFamily="49" charset="0"/>
+                <a:ea typeface="JetBrains Mono" panose="02000009000000000000" pitchFamily="49" charset="0"/>
+                <a:cs typeface="JetBrains Mono" panose="02000009000000000000" pitchFamily="49" charset="0"/>
+              </a:rPr>
+              <a:t>no flags/</a:t>
+            </a:r>
+            <a:r>
+              <a:rPr lang="en-GB" sz="1100" dirty="0" err="1">
+                <a:solidFill>
+                  <a:prstClr val="black"/>
+                </a:solidFill>
+                <a:latin typeface="JetBrains Mono" panose="02000009000000000000" pitchFamily="49" charset="0"/>
+                <a:ea typeface="JetBrains Mono" panose="02000009000000000000" pitchFamily="49" charset="0"/>
+                <a:cs typeface="JetBrains Mono" panose="02000009000000000000" pitchFamily="49" charset="0"/>
+              </a:rPr>
+              <a:t>fcsr</a:t>
+            </a:r>
+            <a:endParaRPr lang="en-GB" sz="1100" dirty="0">
+              <a:solidFill>
+                <a:prstClr val="black"/>
+              </a:solidFill>
+              <a:latin typeface="JetBrains Mono" panose="02000009000000000000" pitchFamily="49" charset="0"/>
+              <a:ea typeface="JetBrains Mono" panose="02000009000000000000" pitchFamily="49" charset="0"/>
+              <a:cs typeface="JetBrains Mono" panose="02000009000000000000" pitchFamily="49" charset="0"/>
+            </a:endParaRPr>
+          </a:p>
+          <a:p>
+            <a:pPr marL="0" indent="0">
+              <a:buNone/>
+              <a:defRPr/>
+            </a:pPr>
+            <a:r>
+              <a:rPr lang="en-GB" sz="1600" dirty="0">
+                <a:solidFill>
+                  <a:prstClr val="black"/>
+                </a:solidFill>
+                <a:latin typeface="JetBrains Mono" panose="02000009000000000000" pitchFamily="49" charset="0"/>
+                <a:ea typeface="JetBrains Mono" panose="02000009000000000000" pitchFamily="49" charset="0"/>
+                <a:cs typeface="JetBrains Mono" panose="02000009000000000000" pitchFamily="49" charset="0"/>
+              </a:rPr>
+              <a:t>RV32V vector extension (limited)</a:t>
+            </a:r>
+          </a:p>
+          <a:p>
+            <a:pPr marL="457200" lvl="1" indent="0">
+              <a:buNone/>
+              <a:defRPr/>
+            </a:pPr>
+            <a:r>
+              <a:rPr lang="en-GB" sz="1100" dirty="0">
+                <a:solidFill>
+                  <a:prstClr val="black"/>
+                </a:solidFill>
+                <a:latin typeface="JetBrains Mono" panose="02000009000000000000" pitchFamily="49" charset="0"/>
+                <a:ea typeface="JetBrains Mono" panose="02000009000000000000" pitchFamily="49" charset="0"/>
+                <a:cs typeface="JetBrains Mono" panose="02000009000000000000" pitchFamily="49" charset="0"/>
+              </a:rPr>
+              <a:t>LMUL 1, ELEN 32, VLEN 128/256/512</a:t>
+            </a:r>
+          </a:p>
           <a:p>
             <a:pPr marL="0" indent="0">
               <a:buNone/>
@@ -3567,7 +3768,7 @@
                 <a:ea typeface="JetBrains Mono" panose="02000009000000000000" pitchFamily="49" charset="0"/>
                 <a:cs typeface="JetBrains Mono" panose="02000009000000000000" pitchFamily="49" charset="0"/>
               </a:rPr>
-              <a:t>seven-stage pipeline</a:t>
+              <a:t>Seven-stage pipeline:</a:t>
             </a:r>
           </a:p>
           <a:p>
@@ -3575,28 +3776,34 @@
               <a:buNone/>
             </a:pPr>
             <a:r>
-              <a:rPr lang="en-GB" sz="1000" dirty="0">
+              <a:rPr lang="en-GB" sz="1100" dirty="0">
                 <a:latin typeface="JetBrains Mono" panose="02000009000000000000" pitchFamily="49" charset="0"/>
                 <a:ea typeface="JetBrains Mono" panose="02000009000000000000" pitchFamily="49" charset="0"/>
                 <a:cs typeface="JetBrains Mono" panose="02000009000000000000" pitchFamily="49" charset="0"/>
               </a:rPr>
-              <a:t>fetch -&gt; decode -&gt; dispatch -&gt; issue</a:t>
-            </a:r>
-            <a:br>
-              <a:rPr lang="en-GB" sz="1000" dirty="0">
+              <a:t>fetch -&gt; decode -&gt; dispatch -&gt; issue -&gt; execute -&gt; writeback -&gt; commit</a:t>
+            </a:r>
+          </a:p>
+          <a:p>
+            <a:pPr marL="0" indent="0">
+              <a:buNone/>
+            </a:pPr>
+            <a:r>
+              <a:rPr lang="en-GB" sz="1600" dirty="0">
+                <a:solidFill>
+                  <a:prstClr val="black"/>
+                </a:solidFill>
                 <a:latin typeface="JetBrains Mono" panose="02000009000000000000" pitchFamily="49" charset="0"/>
                 <a:ea typeface="JetBrains Mono" panose="02000009000000000000" pitchFamily="49" charset="0"/>
                 <a:cs typeface="JetBrains Mono" panose="02000009000000000000" pitchFamily="49" charset="0"/>
               </a:rPr>
-            </a:br>
-            <a:r>
-              <a:rPr lang="en-GB" sz="1000" dirty="0">
-                <a:latin typeface="JetBrains Mono" panose="02000009000000000000" pitchFamily="49" charset="0"/>
-                <a:ea typeface="JetBrains Mono" panose="02000009000000000000" pitchFamily="49" charset="0"/>
-                <a:cs typeface="JetBrains Mono" panose="02000009000000000000" pitchFamily="49" charset="0"/>
-              </a:rPr>
-              <a:t>-&gt; execute -&gt; writeback -&gt; commit</a:t>
-            </a:r>
+              <a:t>32-wide integer, float and vector register files</a:t>
+            </a:r>
+            <a:endParaRPr lang="en-GB" sz="1600" dirty="0">
+              <a:latin typeface="JetBrains Mono" panose="02000009000000000000" pitchFamily="49" charset="0"/>
+              <a:ea typeface="JetBrains Mono" panose="02000009000000000000" pitchFamily="49" charset="0"/>
+              <a:cs typeface="JetBrains Mono" panose="02000009000000000000" pitchFamily="49" charset="0"/>
+            </a:endParaRPr>
           </a:p>
           <a:p>
             <a:pPr marL="0" indent="0">
@@ -3608,7 +3815,7 @@
                 <a:ea typeface="JetBrains Mono" panose="02000009000000000000" pitchFamily="49" charset="0"/>
                 <a:cs typeface="JetBrains Mono" panose="02000009000000000000" pitchFamily="49" charset="0"/>
               </a:rPr>
-              <a:t>configurable fetch/issue/commit widths</a:t>
+              <a:t>Out-of-order issue via reservation stations</a:t>
             </a:r>
           </a:p>
           <a:p>
@@ -3621,7 +3828,7 @@
                 <a:ea typeface="JetBrains Mono" panose="02000009000000000000" pitchFamily="49" charset="0"/>
                 <a:cs typeface="JetBrains Mono" panose="02000009000000000000" pitchFamily="49" charset="0"/>
               </a:rPr>
-              <a:t>configurable number of execution units</a:t>
+              <a:t>In-order commit via 64-wide re-order buffer</a:t>
             </a:r>
           </a:p>
           <a:p>
@@ -3634,7 +3841,7 @@
                 <a:ea typeface="JetBrains Mono" panose="02000009000000000000" pitchFamily="49" charset="0"/>
                 <a:cs typeface="JetBrains Mono" panose="02000009000000000000" pitchFamily="49" charset="0"/>
               </a:rPr>
-              <a:t>in-order issue to reservation stations</a:t>
+              <a:t>Renaming via tag-based register alias tables</a:t>
             </a:r>
           </a:p>
           <a:p>
@@ -3647,7 +3854,7 @@
                 <a:ea typeface="JetBrains Mono" panose="02000009000000000000" pitchFamily="49" charset="0"/>
                 <a:cs typeface="JetBrains Mono" panose="02000009000000000000" pitchFamily="49" charset="0"/>
               </a:rPr>
-              <a:t>in-order commit via re-order buffer</a:t>
+              <a:t>Configurable fetch/issue/commit widths</a:t>
             </a:r>
           </a:p>
           <a:p>
@@ -3660,7 +3867,7 @@
                 <a:ea typeface="JetBrains Mono" panose="02000009000000000000" pitchFamily="49" charset="0"/>
                 <a:cs typeface="JetBrains Mono" panose="02000009000000000000" pitchFamily="49" charset="0"/>
               </a:rPr>
-              <a:t>integer, float and vector register files</a:t>
+              <a:t>Configurable number of execution units</a:t>
             </a:r>
           </a:p>
           <a:p>
@@ -3673,7 +3880,59 @@
                 <a:ea typeface="JetBrains Mono" panose="02000009000000000000" pitchFamily="49" charset="0"/>
                 <a:cs typeface="JetBrains Mono" panose="02000009000000000000" pitchFamily="49" charset="0"/>
               </a:rPr>
-              <a:t>tag-based register alias tables</a:t>
+              <a:t>Multiple branch prediction policies:</a:t>
+            </a:r>
+          </a:p>
+          <a:p>
+            <a:pPr marL="457200" lvl="1" indent="0">
+              <a:buNone/>
+            </a:pPr>
+            <a:r>
+              <a:rPr lang="en-GB" sz="1100" dirty="0">
+                <a:latin typeface="JetBrains Mono" panose="02000009000000000000" pitchFamily="49" charset="0"/>
+                <a:ea typeface="JetBrains Mono" panose="02000009000000000000" pitchFamily="49" charset="0"/>
+                <a:cs typeface="JetBrains Mono" panose="02000009000000000000" pitchFamily="49" charset="0"/>
+              </a:rPr>
+              <a:t>static taken</a:t>
+            </a:r>
+          </a:p>
+          <a:p>
+            <a:pPr marL="457200" lvl="1" indent="0">
+              <a:buNone/>
+            </a:pPr>
+            <a:r>
+              <a:rPr lang="en-GB" sz="1100" dirty="0">
+                <a:latin typeface="JetBrains Mono" panose="02000009000000000000" pitchFamily="49" charset="0"/>
+                <a:ea typeface="JetBrains Mono" panose="02000009000000000000" pitchFamily="49" charset="0"/>
+                <a:cs typeface="JetBrains Mono" panose="02000009000000000000" pitchFamily="49" charset="0"/>
+              </a:rPr>
+              <a:t>static not taken</a:t>
+            </a:r>
+          </a:p>
+          <a:p>
+            <a:pPr marL="457200" lvl="1" indent="0">
+              <a:buNone/>
+            </a:pPr>
+            <a:r>
+              <a:rPr lang="en-GB" sz="1100" dirty="0">
+                <a:latin typeface="JetBrains Mono" panose="02000009000000000000" pitchFamily="49" charset="0"/>
+                <a:ea typeface="JetBrains Mono" panose="02000009000000000000" pitchFamily="49" charset="0"/>
+                <a:cs typeface="JetBrains Mono" panose="02000009000000000000" pitchFamily="49" charset="0"/>
+              </a:rPr>
+              <a:t>static backward taken forward not taken</a:t>
+            </a:r>
+          </a:p>
+          <a:p>
+            <a:pPr marL="457200" lvl="1" indent="0">
+              <a:buNone/>
+            </a:pPr>
+            <a:r>
+              <a:rPr lang="en-GB" sz="1100" dirty="0">
+                <a:latin typeface="JetBrains Mono" panose="02000009000000000000" pitchFamily="49" charset="0"/>
+                <a:ea typeface="JetBrains Mono" panose="02000009000000000000" pitchFamily="49" charset="0"/>
+                <a:cs typeface="JetBrains Mono" panose="02000009000000000000" pitchFamily="49" charset="0"/>
+              </a:rPr>
+              <a:t>dynamic two-bit saturating counter</a:t>
             </a:r>
           </a:p>
           <a:p>
@@ -3686,7 +3945,7 @@
                 <a:ea typeface="JetBrains Mono" panose="02000009000000000000" pitchFamily="49" charset="0"/>
                 <a:cs typeface="JetBrains Mono" panose="02000009000000000000" pitchFamily="49" charset="0"/>
               </a:rPr>
-              <a:t>multiple branch prediction policies</a:t>
+              <a:t>Relaxed memory policy:</a:t>
             </a:r>
           </a:p>
           <a:p>
@@ -3694,12 +3953,12 @@
               <a:buNone/>
             </a:pPr>
             <a:r>
-              <a:rPr lang="en-GB" sz="1000" dirty="0">
+              <a:rPr lang="en-GB" sz="1100" dirty="0">
                 <a:latin typeface="JetBrains Mono" panose="02000009000000000000" pitchFamily="49" charset="0"/>
                 <a:ea typeface="JetBrains Mono" panose="02000009000000000000" pitchFamily="49" charset="0"/>
                 <a:cs typeface="JetBrains Mono" panose="02000009000000000000" pitchFamily="49" charset="0"/>
               </a:rPr>
-              <a:t>static taken</a:t>
+              <a:t>non-overlapping loads bypass pending older stores</a:t>
             </a:r>
           </a:p>
           <a:p>
@@ -3707,82 +3966,12 @@
               <a:buNone/>
             </a:pPr>
             <a:r>
-              <a:rPr lang="en-GB" sz="1000" dirty="0">
+              <a:rPr lang="en-GB" sz="1100" dirty="0">
                 <a:latin typeface="JetBrains Mono" panose="02000009000000000000" pitchFamily="49" charset="0"/>
                 <a:ea typeface="JetBrains Mono" panose="02000009000000000000" pitchFamily="49" charset="0"/>
                 <a:cs typeface="JetBrains Mono" panose="02000009000000000000" pitchFamily="49" charset="0"/>
               </a:rPr>
-              <a:t>static not taken</a:t>
-            </a:r>
-          </a:p>
-          <a:p>
-            <a:pPr marL="457200" lvl="1" indent="0">
-              <a:buNone/>
-            </a:pPr>
-            <a:r>
-              <a:rPr lang="en-GB" sz="1000" dirty="0">
-                <a:latin typeface="JetBrains Mono" panose="02000009000000000000" pitchFamily="49" charset="0"/>
-                <a:ea typeface="JetBrains Mono" panose="02000009000000000000" pitchFamily="49" charset="0"/>
-                <a:cs typeface="JetBrains Mono" panose="02000009000000000000" pitchFamily="49" charset="0"/>
-              </a:rPr>
-              <a:t>one-bit saturating counter</a:t>
-            </a:r>
-          </a:p>
-          <a:p>
-            <a:pPr marL="457200" lvl="1" indent="0">
-              <a:buNone/>
-            </a:pPr>
-            <a:r>
-              <a:rPr lang="en-GB" sz="1000" dirty="0">
-                <a:latin typeface="JetBrains Mono" panose="02000009000000000000" pitchFamily="49" charset="0"/>
-                <a:ea typeface="JetBrains Mono" panose="02000009000000000000" pitchFamily="49" charset="0"/>
-                <a:cs typeface="JetBrains Mono" panose="02000009000000000000" pitchFamily="49" charset="0"/>
-              </a:rPr>
-              <a:t>two-bit saturating counter</a:t>
-            </a:r>
-            <a:endParaRPr lang="en-GB" sz="1600" dirty="0">
-              <a:latin typeface="JetBrains Mono" panose="02000009000000000000" pitchFamily="49" charset="0"/>
-              <a:ea typeface="JetBrains Mono" panose="02000009000000000000" pitchFamily="49" charset="0"/>
-              <a:cs typeface="JetBrains Mono" panose="02000009000000000000" pitchFamily="49" charset="0"/>
-            </a:endParaRPr>
-          </a:p>
-          <a:p>
-            <a:pPr marL="0" indent="0">
-              <a:buNone/>
-            </a:pPr>
-            <a:r>
-              <a:rPr lang="en-GB" sz="1600" dirty="0">
-                <a:latin typeface="JetBrains Mono" panose="02000009000000000000" pitchFamily="49" charset="0"/>
-                <a:ea typeface="JetBrains Mono" panose="02000009000000000000" pitchFamily="49" charset="0"/>
-                <a:cs typeface="JetBrains Mono" panose="02000009000000000000" pitchFamily="49" charset="0"/>
-              </a:rPr>
-              <a:t>memory policy:</a:t>
-            </a:r>
-          </a:p>
-          <a:p>
-            <a:pPr marL="457200" lvl="1" indent="0">
-              <a:buNone/>
-            </a:pPr>
-            <a:r>
-              <a:rPr lang="en-GB" sz="1000" dirty="0">
-                <a:latin typeface="JetBrains Mono" panose="02000009000000000000" pitchFamily="49" charset="0"/>
-                <a:ea typeface="JetBrains Mono" panose="02000009000000000000" pitchFamily="49" charset="0"/>
-                <a:cs typeface="JetBrains Mono" panose="02000009000000000000" pitchFamily="49" charset="0"/>
-              </a:rPr>
-              <a:t>non-overlapping loads bypass pending stores</a:t>
-            </a:r>
-          </a:p>
-          <a:p>
-            <a:pPr marL="457200" lvl="1" indent="0">
-              <a:buNone/>
-            </a:pPr>
-            <a:r>
-              <a:rPr lang="en-GB" sz="1000" dirty="0">
-                <a:latin typeface="JetBrains Mono" panose="02000009000000000000" pitchFamily="49" charset="0"/>
-                <a:ea typeface="JetBrains Mono" panose="02000009000000000000" pitchFamily="49" charset="0"/>
-                <a:cs typeface="JetBrains Mono" panose="02000009000000000000" pitchFamily="49" charset="0"/>
-              </a:rPr>
-              <a:t>pending stores with known values are forwarded</a:t>
+              <a:t>overlapping loads have older stores forwarded at byte level</a:t>
             </a:r>
           </a:p>
         </p:txBody>
@@ -3979,38 +4168,288 @@
             </a:lvl9pPr>
           </a:lstStyle>
           <a:p>
-            <a:pPr marL="0" marR="0" lvl="0" indent="0" algn="l" defTabSz="914400" rtl="0" eaLnBrk="1" fontAlgn="auto" latinLnBrk="0" hangingPunct="1">
+            <a:pPr marL="0" indent="0">
+              <a:buNone/>
+              <a:defRPr/>
+            </a:pPr>
+            <a:endParaRPr kumimoji="0" lang="en-GB" sz="1600" b="0" i="0" u="none" strike="noStrike" kern="1200" cap="none" spc="0" normalizeH="0" baseline="0" noProof="0" dirty="0">
+              <a:ln>
+                <a:noFill/>
+              </a:ln>
+              <a:solidFill>
+                <a:prstClr val="black"/>
+              </a:solidFill>
+              <a:effectLst/>
+              <a:uLnTx/>
+              <a:uFillTx/>
+              <a:latin typeface="JetBrains Mono" panose="02000009000000000000" pitchFamily="49" charset="0"/>
+              <a:ea typeface="JetBrains Mono" panose="02000009000000000000" pitchFamily="49" charset="0"/>
+              <a:cs typeface="JetBrains Mono" panose="02000009000000000000" pitchFamily="49" charset="0"/>
+            </a:endParaRPr>
+          </a:p>
+        </p:txBody>
+      </p:sp>
+      <p:sp>
+        <p:nvSpPr>
+          <p:cNvPr id="2" name="Content Placeholder 2">
+            <a:extLst>
+              <a:ext uri="{FF2B5EF4-FFF2-40B4-BE49-F238E27FC236}">
+                <a16:creationId xmlns:a16="http://schemas.microsoft.com/office/drawing/2014/main" id="{28B1C536-722D-D79D-082E-72655AE2D13F}"/>
+              </a:ext>
+            </a:extLst>
+          </p:cNvPr>
+          <p:cNvSpPr txBox="1">
+            <a:spLocks/>
+          </p:cNvSpPr>
+          <p:nvPr/>
+        </p:nvSpPr>
+        <p:spPr>
+          <a:xfrm>
+            <a:off x="6750604" y="559952"/>
+            <a:ext cx="4698446" cy="5860750"/>
+          </a:xfrm>
+          <a:prstGeom prst="rect">
+            <a:avLst/>
+          </a:prstGeom>
+        </p:spPr>
+        <p:txBody>
+          <a:bodyPr vert="horz" lIns="91440" tIns="45720" rIns="91440" bIns="45720" rtlCol="0">
+            <a:normAutofit/>
+          </a:bodyPr>
+          <a:lstStyle>
+            <a:lvl1pPr marL="228600" indent="-228600" algn="l" defTabSz="914400" rtl="0" eaLnBrk="1" latinLnBrk="0" hangingPunct="1">
               <a:lnSpc>
                 <a:spcPct val="90000"/>
               </a:lnSpc>
               <a:spcBef>
                 <a:spcPts val="1000"/>
               </a:spcBef>
-              <a:spcAft>
-                <a:spcPts val="0"/>
-              </a:spcAft>
-              <a:buClrTx/>
-              <a:buSzTx/>
-              <a:buNone/>
-              <a:tabLst/>
+              <a:buFont typeface="Arial" panose="020B0604020202020204" pitchFamily="34" charset="0"/>
+              <a:buChar char="•"/>
+              <a:defRPr sz="2800" kern="1200">
+                <a:solidFill>
+                  <a:schemeClr val="tx1"/>
+                </a:solidFill>
+                <a:latin typeface="+mn-lt"/>
+                <a:ea typeface="+mn-ea"/>
+                <a:cs typeface="+mn-cs"/>
+              </a:defRPr>
+            </a:lvl1pPr>
+            <a:lvl2pPr marL="685800" indent="-228600" algn="l" defTabSz="914400" rtl="0" eaLnBrk="1" latinLnBrk="0" hangingPunct="1">
+              <a:lnSpc>
+                <a:spcPct val="90000"/>
+              </a:lnSpc>
+              <a:spcBef>
+                <a:spcPts val="500"/>
+              </a:spcBef>
+              <a:buFont typeface="Arial" panose="020B0604020202020204" pitchFamily="34" charset="0"/>
+              <a:buChar char="•"/>
+              <a:defRPr sz="2400" kern="1200">
+                <a:solidFill>
+                  <a:schemeClr val="tx1"/>
+                </a:solidFill>
+                <a:latin typeface="+mn-lt"/>
+                <a:ea typeface="+mn-ea"/>
+                <a:cs typeface="+mn-cs"/>
+              </a:defRPr>
+            </a:lvl2pPr>
+            <a:lvl3pPr marL="1143000" indent="-228600" algn="l" defTabSz="914400" rtl="0" eaLnBrk="1" latinLnBrk="0" hangingPunct="1">
+              <a:lnSpc>
+                <a:spcPct val="90000"/>
+              </a:lnSpc>
+              <a:spcBef>
+                <a:spcPts val="500"/>
+              </a:spcBef>
+              <a:buFont typeface="Arial" panose="020B0604020202020204" pitchFamily="34" charset="0"/>
+              <a:buChar char="•"/>
+              <a:defRPr sz="2000" kern="1200">
+                <a:solidFill>
+                  <a:schemeClr val="tx1"/>
+                </a:solidFill>
+                <a:latin typeface="+mn-lt"/>
+                <a:ea typeface="+mn-ea"/>
+                <a:cs typeface="+mn-cs"/>
+              </a:defRPr>
+            </a:lvl3pPr>
+            <a:lvl4pPr marL="1600200" indent="-228600" algn="l" defTabSz="914400" rtl="0" eaLnBrk="1" latinLnBrk="0" hangingPunct="1">
+              <a:lnSpc>
+                <a:spcPct val="90000"/>
+              </a:lnSpc>
+              <a:spcBef>
+                <a:spcPts val="500"/>
+              </a:spcBef>
+              <a:buFont typeface="Arial" panose="020B0604020202020204" pitchFamily="34" charset="0"/>
+              <a:buChar char="•"/>
+              <a:defRPr sz="1800" kern="1200">
+                <a:solidFill>
+                  <a:schemeClr val="tx1"/>
+                </a:solidFill>
+                <a:latin typeface="+mn-lt"/>
+                <a:ea typeface="+mn-ea"/>
+                <a:cs typeface="+mn-cs"/>
+              </a:defRPr>
+            </a:lvl4pPr>
+            <a:lvl5pPr marL="2057400" indent="-228600" algn="l" defTabSz="914400" rtl="0" eaLnBrk="1" latinLnBrk="0" hangingPunct="1">
+              <a:lnSpc>
+                <a:spcPct val="90000"/>
+              </a:lnSpc>
+              <a:spcBef>
+                <a:spcPts val="500"/>
+              </a:spcBef>
+              <a:buFont typeface="Arial" panose="020B0604020202020204" pitchFamily="34" charset="0"/>
+              <a:buChar char="•"/>
+              <a:defRPr sz="1800" kern="1200">
+                <a:solidFill>
+                  <a:schemeClr val="tx1"/>
+                </a:solidFill>
+                <a:latin typeface="+mn-lt"/>
+                <a:ea typeface="+mn-ea"/>
+                <a:cs typeface="+mn-cs"/>
+              </a:defRPr>
+            </a:lvl5pPr>
+            <a:lvl6pPr marL="2514600" indent="-228600" algn="l" defTabSz="914400" rtl="0" eaLnBrk="1" latinLnBrk="0" hangingPunct="1">
+              <a:lnSpc>
+                <a:spcPct val="90000"/>
+              </a:lnSpc>
+              <a:spcBef>
+                <a:spcPts val="500"/>
+              </a:spcBef>
+              <a:buFont typeface="Arial" panose="020B0604020202020204" pitchFamily="34" charset="0"/>
+              <a:buChar char="•"/>
+              <a:defRPr sz="1800" kern="1200">
+                <a:solidFill>
+                  <a:schemeClr val="tx1"/>
+                </a:solidFill>
+                <a:latin typeface="+mn-lt"/>
+                <a:ea typeface="+mn-ea"/>
+                <a:cs typeface="+mn-cs"/>
+              </a:defRPr>
+            </a:lvl6pPr>
+            <a:lvl7pPr marL="2971800" indent="-228600" algn="l" defTabSz="914400" rtl="0" eaLnBrk="1" latinLnBrk="0" hangingPunct="1">
+              <a:lnSpc>
+                <a:spcPct val="90000"/>
+              </a:lnSpc>
+              <a:spcBef>
+                <a:spcPts val="500"/>
+              </a:spcBef>
+              <a:buFont typeface="Arial" panose="020B0604020202020204" pitchFamily="34" charset="0"/>
+              <a:buChar char="•"/>
+              <a:defRPr sz="1800" kern="1200">
+                <a:solidFill>
+                  <a:schemeClr val="tx1"/>
+                </a:solidFill>
+                <a:latin typeface="+mn-lt"/>
+                <a:ea typeface="+mn-ea"/>
+                <a:cs typeface="+mn-cs"/>
+              </a:defRPr>
+            </a:lvl7pPr>
+            <a:lvl8pPr marL="3429000" indent="-228600" algn="l" defTabSz="914400" rtl="0" eaLnBrk="1" latinLnBrk="0" hangingPunct="1">
+              <a:lnSpc>
+                <a:spcPct val="90000"/>
+              </a:lnSpc>
+              <a:spcBef>
+                <a:spcPts val="500"/>
+              </a:spcBef>
+              <a:buFont typeface="Arial" panose="020B0604020202020204" pitchFamily="34" charset="0"/>
+              <a:buChar char="•"/>
+              <a:defRPr sz="1800" kern="1200">
+                <a:solidFill>
+                  <a:schemeClr val="tx1"/>
+                </a:solidFill>
+                <a:latin typeface="+mn-lt"/>
+                <a:ea typeface="+mn-ea"/>
+                <a:cs typeface="+mn-cs"/>
+              </a:defRPr>
+            </a:lvl8pPr>
+            <a:lvl9pPr marL="3886200" indent="-228600" algn="l" defTabSz="914400" rtl="0" eaLnBrk="1" latinLnBrk="0" hangingPunct="1">
+              <a:lnSpc>
+                <a:spcPct val="90000"/>
+              </a:lnSpc>
+              <a:spcBef>
+                <a:spcPts val="500"/>
+              </a:spcBef>
+              <a:buFont typeface="Arial" panose="020B0604020202020204" pitchFamily="34" charset="0"/>
+              <a:buChar char="•"/>
+              <a:defRPr sz="1800" kern="1200">
+                <a:solidFill>
+                  <a:schemeClr val="tx1"/>
+                </a:solidFill>
+                <a:latin typeface="+mn-lt"/>
+                <a:ea typeface="+mn-ea"/>
+                <a:cs typeface="+mn-cs"/>
+              </a:defRPr>
+            </a:lvl9pPr>
+          </a:lstStyle>
+          <a:p>
+            <a:pPr marL="0" indent="0">
+              <a:buFont typeface="Arial" panose="020B0604020202020204" pitchFamily="34" charset="0"/>
+              <a:buNone/>
               <a:defRPr/>
             </a:pPr>
             <a:r>
-              <a:rPr kumimoji="0" lang="en-GB" sz="1600" b="0" i="0" u="none" strike="noStrike" kern="1200" cap="none" spc="0" normalizeH="0" baseline="0" noProof="0" dirty="0">
-                <a:ln>
-                  <a:noFill/>
-                </a:ln>
+              <a:rPr lang="en-GB" sz="1500" dirty="0">
                 <a:solidFill>
                   <a:prstClr val="black"/>
                 </a:solidFill>
-                <a:effectLst/>
-                <a:uLnTx/>
-                <a:uFillTx/>
                 <a:latin typeface="JetBrains Mono" panose="02000009000000000000" pitchFamily="49" charset="0"/>
                 <a:ea typeface="JetBrains Mono" panose="02000009000000000000" pitchFamily="49" charset="0"/>
                 <a:cs typeface="JetBrains Mono" panose="02000009000000000000" pitchFamily="49" charset="0"/>
               </a:rPr>
-              <a:t>minimal rv32imf_v... ISA</a:t>
+              <a:t>Interactive terminal UI</a:t>
+            </a:r>
+          </a:p>
+          <a:p>
+            <a:pPr marL="457200" lvl="1" indent="0">
+              <a:buFont typeface="Arial" panose="020B0604020202020204" pitchFamily="34" charset="0"/>
+              <a:buNone/>
+              <a:defRPr/>
+            </a:pPr>
+            <a:r>
+              <a:rPr lang="en-GB" sz="1000" dirty="0">
+                <a:solidFill>
+                  <a:prstClr val="black"/>
+                </a:solidFill>
+                <a:latin typeface="JetBrains Mono" panose="02000009000000000000" pitchFamily="49" charset="0"/>
+                <a:ea typeface="JetBrains Mono" panose="02000009000000000000" pitchFamily="49" charset="0"/>
+                <a:cs typeface="JetBrains Mono" panose="02000009000000000000" pitchFamily="49" charset="0"/>
+              </a:rPr>
+              <a:t>step/run, headless mode</a:t>
+            </a:r>
+          </a:p>
+          <a:p>
+            <a:pPr marL="457200" lvl="1" indent="0">
+              <a:buFont typeface="Arial" panose="020B0604020202020204" pitchFamily="34" charset="0"/>
+              <a:buNone/>
+              <a:defRPr/>
+            </a:pPr>
+            <a:r>
+              <a:rPr lang="en-GB" sz="1000" dirty="0">
+                <a:solidFill>
+                  <a:prstClr val="black"/>
+                </a:solidFill>
+                <a:latin typeface="JetBrains Mono" panose="02000009000000000000" pitchFamily="49" charset="0"/>
+                <a:ea typeface="JetBrains Mono" panose="02000009000000000000" pitchFamily="49" charset="0"/>
+                <a:cs typeface="JetBrains Mono" panose="02000009000000000000" pitchFamily="49" charset="0"/>
+              </a:rPr>
+              <a:t>registers, stack</a:t>
+            </a:r>
+          </a:p>
+          <a:p>
+            <a:pPr marL="0" indent="0">
+              <a:buFont typeface="Arial" panose="020B0604020202020204" pitchFamily="34" charset="0"/>
+              <a:buNone/>
+              <a:defRPr/>
+            </a:pPr>
+            <a:r>
+              <a:rPr lang="en-GB" sz="1500" dirty="0">
+                <a:solidFill>
+                  <a:prstClr val="black"/>
+                </a:solidFill>
+                <a:latin typeface="JetBrains Mono" panose="02000009000000000000" pitchFamily="49" charset="0"/>
+                <a:ea typeface="JetBrains Mono" panose="02000009000000000000" pitchFamily="49" charset="0"/>
+                <a:cs typeface="JetBrains Mono" panose="02000009000000000000" pitchFamily="49" charset="0"/>
+              </a:rPr>
+              <a:t>Stack handling, function calls</a:t>
             </a:r>
           </a:p>
         </p:txBody>

</xml_diff>